<commit_message>
Updated plots and portuguese version of One Slide
</commit_message>
<xml_diff>
--- a/utils/OneSlide/One-Slide.pptx
+++ b/utils/OneSlide/One-Slide.pptx
@@ -9,7 +9,7 @@
   </p:notesMasterIdLst>
   <p:sldIdLst>
     <p:sldId id="257" r:id="rId2"/>
-    <p:sldId id="258" r:id="rId3"/>
+    <p:sldId id="260" r:id="rId3"/>
   </p:sldIdLst>
   <p:sldSz cx="9144000" cy="5143500" type="screen16x9"/>
   <p:notesSz cx="6858000" cy="9144000"/>
@@ -1079,7 +1079,7 @@
     </p:spTree>
     <p:extLst>
       <p:ext uri="{BB962C8B-B14F-4D97-AF65-F5344CB8AC3E}">
-        <p14:creationId xmlns:p14="http://schemas.microsoft.com/office/powerpoint/2010/main" val="949764812"/>
+        <p14:creationId xmlns:p14="http://schemas.microsoft.com/office/powerpoint/2010/main" val="2556996014"/>
       </p:ext>
     </p:extLst>
   </p:cSld>
@@ -8857,10 +8857,10 @@
         </p:nvGrpSpPr>
         <p:grpSpPr>
           <a:xfrm>
-            <a:off x="35775" y="-25250"/>
-            <a:ext cx="9148200" cy="5097700"/>
-            <a:chOff x="-2100" y="0"/>
-            <a:chExt cx="9148200" cy="5097700"/>
+            <a:off x="65307" y="47902"/>
+            <a:ext cx="9070848" cy="5001768"/>
+            <a:chOff x="27432" y="73152"/>
+            <a:chExt cx="9070848" cy="5001768"/>
           </a:xfrm>
         </p:grpSpPr>
         <p:sp>
@@ -8871,8 +8871,8 @@
           </p:nvSpPr>
           <p:spPr>
             <a:xfrm>
-              <a:off x="30050" y="73350"/>
-              <a:ext cx="4411200" cy="542100"/>
+              <a:off x="27432" y="73152"/>
+              <a:ext cx="3611880" cy="502920"/>
             </a:xfrm>
             <a:prstGeom prst="rect">
               <a:avLst/>
@@ -8926,7 +8926,7 @@
                   <a:cs typeface="Times New Roman"/>
                   <a:sym typeface="Times New Roman"/>
                 </a:rPr>
-                <a:t>1. FOLLOW-UP - OWNER</a:t>
+                <a:t>1. ACOMPANHAMENTO - RESPONSÁVEL</a:t>
               </a:r>
               <a:endParaRPr dirty="0">
                 <a:highlight>
@@ -8962,7 +8962,7 @@
                   <a:cs typeface="Times New Roman"/>
                   <a:sym typeface="Times New Roman"/>
                 </a:rPr>
-                <a:t>DD/NN/AAAA - DD/MM/AAAA</a:t>
+                <a:t>DD/MM/AAAA - DD/MM/AAAA</a:t>
               </a:r>
               <a:endParaRPr dirty="0"/>
             </a:p>
@@ -8976,8 +8976,8 @@
           </p:nvSpPr>
           <p:spPr>
             <a:xfrm>
-              <a:off x="30050" y="658825"/>
-              <a:ext cx="4411200" cy="768600"/>
+              <a:off x="27432" y="621792"/>
+              <a:ext cx="3611880" cy="896112"/>
             </a:xfrm>
             <a:prstGeom prst="rect">
               <a:avLst/>
@@ -9062,7 +9062,7 @@
                   <a:cs typeface="Times New Roman"/>
                   <a:sym typeface="Times New Roman"/>
                 </a:rPr>
-                <a:t>OBJECTIVE</a:t>
+                <a:t>OBJETIVO</a:t>
               </a:r>
               <a:r>
                 <a:rPr lang="pt-BR" sz="900" b="0" i="0" u="none" strike="noStrike" cap="none" dirty="0">
@@ -9084,14 +9084,14 @@
                   <a:latin typeface="Times New Roman" panose="02020603050405020304" pitchFamily="18" charset="0"/>
                   <a:cs typeface="Times New Roman" panose="02020603050405020304" pitchFamily="18" charset="0"/>
                 </a:rPr>
-                <a:t>Answers: </a:t>
+                <a:t>Responde: </a:t>
               </a:r>
               <a:r>
                 <a:rPr lang="en-US" sz="800" dirty="0">
                   <a:latin typeface="Times New Roman" panose="02020603050405020304" pitchFamily="18" charset="0"/>
                   <a:cs typeface="Times New Roman" panose="02020603050405020304" pitchFamily="18" charset="0"/>
                 </a:rPr>
-                <a:t>what this cycle is for.</a:t>
+                <a:t>para que serve este ciclo.</a:t>
               </a:r>
             </a:p>
             <a:p>
@@ -9115,7 +9115,7 @@
                   <a:latin typeface="Times New Roman" panose="02020603050405020304" pitchFamily="18" charset="0"/>
                   <a:cs typeface="Times New Roman" panose="02020603050405020304" pitchFamily="18" charset="0"/>
                 </a:rPr>
-                <a:t>Written and unchanged for all six weekly slides. One sentence, stating an outcome with a condition that can be checked, not an activity:</a:t>
+                <a:t>Definido no início do ciclo e inalterado nos seis slides semanais. Uma frase: um resultado com condição verificável, não uma atividade.</a:t>
               </a:r>
             </a:p>
             <a:p>
@@ -9141,7 +9141,7 @@
                   <a:latin typeface="Times New Roman" panose="02020603050405020304" pitchFamily="18" charset="0"/>
                   <a:cs typeface="Times New Roman" panose="02020603050405020304" pitchFamily="18" charset="0"/>
                 </a:rPr>
-                <a:t>Deliver a steady-state model of the commercial heat pump that reproduces the measured COP within ±10% over a sink temperature of 60 to 95 °C.</a:t>
+                <a:t>Entregar um modelo em regime permanente da bomba de calor comercial que reproduza o COP medido com desvio de ±10% na faixa de temperatura de fonte quente de 60 a 95 °C.</a:t>
               </a:r>
               <a:endParaRPr sz="800" i="1" dirty="0">
                 <a:solidFill>
@@ -9199,32 +9199,6 @@
             </a:p>
           </p:txBody>
         </p:sp>
-        <p:cxnSp>
-          <p:nvCxnSpPr>
-            <p:cNvPr id="147" name="Google Shape;147;p32"/>
-            <p:cNvCxnSpPr/>
-            <p:nvPr/>
-          </p:nvCxnSpPr>
-          <p:spPr>
-            <a:xfrm>
-              <a:off x="4502950" y="0"/>
-              <a:ext cx="12000" cy="3921900"/>
-            </a:xfrm>
-            <a:prstGeom prst="straightConnector1">
-              <a:avLst/>
-            </a:prstGeom>
-            <a:noFill/>
-            <a:ln w="19050" cap="flat" cmpd="sng">
-              <a:solidFill>
-                <a:schemeClr val="dk2"/>
-              </a:solidFill>
-              <a:prstDash val="solid"/>
-              <a:round/>
-              <a:headEnd type="none" w="sm" len="sm"/>
-              <a:tailEnd type="none" w="sm" len="sm"/>
-            </a:ln>
-          </p:spPr>
-        </p:cxnSp>
         <p:sp>
           <p:nvSpPr>
             <p:cNvPr id="148" name="Google Shape;148;p32"/>
@@ -9233,8 +9207,8 @@
           </p:nvSpPr>
           <p:spPr>
             <a:xfrm>
-              <a:off x="4572000" y="73350"/>
-              <a:ext cx="4510500" cy="3797400"/>
+              <a:off x="3730752" y="73152"/>
+              <a:ext cx="5367528" cy="5001768"/>
             </a:xfrm>
             <a:prstGeom prst="rect">
               <a:avLst/>
@@ -9288,7 +9262,7 @@
                   <a:cs typeface="Times New Roman"/>
                   <a:sym typeface="Times New Roman"/>
                 </a:rPr>
-                <a:t>RESULTS</a:t>
+                <a:t>RESULTADOS</a:t>
               </a:r>
               <a:r>
                 <a:rPr lang="pt-BR" sz="900" b="0" i="0" u="none" strike="noStrike" cap="none" dirty="0">
@@ -9310,14 +9284,14 @@
                   <a:latin typeface="Times New Roman" panose="02020603050405020304" pitchFamily="18" charset="0"/>
                   <a:cs typeface="Times New Roman" panose="02020603050405020304" pitchFamily="18" charset="0"/>
                 </a:rPr>
-                <a:t>Answers:</a:t>
+                <a:t>Responde:</a:t>
               </a:r>
               <a:r>
                 <a:rPr lang="en-US" sz="800" dirty="0">
                   <a:latin typeface="Times New Roman" panose="02020603050405020304" pitchFamily="18" charset="0"/>
                   <a:cs typeface="Times New Roman" panose="02020603050405020304" pitchFamily="18" charset="0"/>
                 </a:rPr>
-                <a:t> what do we now know that we didn't last week.</a:t>
+                <a:t> o que sabemos agora que não sabíamos na semana passada.</a:t>
               </a:r>
               <a:endParaRPr sz="800" dirty="0">
                 <a:latin typeface="Times New Roman" panose="02020603050405020304" pitchFamily="18" charset="0"/>
@@ -9362,7 +9336,7 @@
                   <a:latin typeface="Times New Roman" panose="02020603050405020304" pitchFamily="18" charset="0"/>
                   <a:cs typeface="Times New Roman" panose="02020603050405020304" pitchFamily="18" charset="0"/>
                 </a:rPr>
-                <a:t>Evidence, not activity. Data, not narrative</a:t>
+                <a:t>Evidência, não atividade. Dados, não narrativa</a:t>
               </a:r>
               <a:r>
                 <a:rPr lang="en-US" sz="800" b="1" dirty="0">
@@ -9376,7 +9350,7 @@
                   <a:latin typeface="Times New Roman" panose="02020603050405020304" pitchFamily="18" charset="0"/>
                   <a:cs typeface="Times New Roman" panose="02020603050405020304" pitchFamily="18" charset="0"/>
                 </a:rPr>
-                <a:t> Figures, tables, and sentences saying what it shows. </a:t>
+                <a:t> Figuras, tabelas e frases dizendo o que elas mostram. </a:t>
               </a:r>
               <a:endParaRPr sz="800" dirty="0">
                 <a:highlight>
@@ -9452,8 +9426,8 @@
           </p:nvSpPr>
           <p:spPr>
             <a:xfrm>
-              <a:off x="4514950" y="3962500"/>
-              <a:ext cx="4574100" cy="1135200"/>
+              <a:off x="27432" y="3749040"/>
+              <a:ext cx="3611880" cy="1325880"/>
             </a:xfrm>
             <a:prstGeom prst="rect">
               <a:avLst/>
@@ -9538,7 +9512,7 @@
                   <a:cs typeface="Times New Roman"/>
                   <a:sym typeface="Times New Roman"/>
                 </a:rPr>
-                <a:t>NEXT STEPS</a:t>
+                <a:t>PRÓXIMOS PASSOS</a:t>
               </a:r>
               <a:r>
                 <a:rPr lang="pt-BR" sz="900" b="0" i="0" u="none" strike="noStrike" cap="none" dirty="0">
@@ -9560,14 +9534,14 @@
                   <a:latin typeface="Times New Roman" panose="02020603050405020304" pitchFamily="18" charset="0"/>
                   <a:cs typeface="Times New Roman" panose="02020603050405020304" pitchFamily="18" charset="0"/>
                 </a:rPr>
-                <a:t>Answers:</a:t>
+                <a:t>Responde:</a:t>
               </a:r>
               <a:r>
                 <a:rPr lang="en-US" sz="800" dirty="0">
                   <a:latin typeface="Times New Roman" panose="02020603050405020304" pitchFamily="18" charset="0"/>
                   <a:cs typeface="Times New Roman" panose="02020603050405020304" pitchFamily="18" charset="0"/>
                 </a:rPr>
-                <a:t> what will be true at the next meeting.</a:t>
+                <a:t> o que será verdade na próxima reunião.</a:t>
               </a:r>
               <a:endParaRPr lang="en-US" sz="800" dirty="0">
                 <a:highlight>
@@ -9632,7 +9606,49 @@
                   <a:latin typeface="Times New Roman" panose="02020603050405020304" pitchFamily="18" charset="0"/>
                   <a:cs typeface="Times New Roman" panose="02020603050405020304" pitchFamily="18" charset="0"/>
                 </a:rPr>
-                <a:t>Two passes: Before the meeting, the owner drafts their proposed steps. During the meeting, team feedback is added to the same block. The post-meeting version is the record. </a:t>
+                <a:t>Antes da reunião, o responsável redige </a:t>
+              </a:r>
+              <a:r>
+                <a:rPr lang="en-US" sz="800" dirty="0" err="1">
+                  <a:latin typeface="Times New Roman" panose="02020603050405020304" pitchFamily="18" charset="0"/>
+                  <a:cs typeface="Times New Roman" panose="02020603050405020304" pitchFamily="18" charset="0"/>
+                </a:rPr>
+                <a:t>os</a:t>
+              </a:r>
+              <a:r>
+                <a:rPr lang="en-US" sz="800" dirty="0">
+                  <a:latin typeface="Times New Roman" panose="02020603050405020304" pitchFamily="18" charset="0"/>
+                  <a:cs typeface="Times New Roman" panose="02020603050405020304" pitchFamily="18" charset="0"/>
+                </a:rPr>
+                <a:t> </a:t>
+              </a:r>
+              <a:r>
+                <a:rPr lang="en-US" sz="800" dirty="0" err="1">
+                  <a:latin typeface="Times New Roman" panose="02020603050405020304" pitchFamily="18" charset="0"/>
+                  <a:cs typeface="Times New Roman" panose="02020603050405020304" pitchFamily="18" charset="0"/>
+                </a:rPr>
+                <a:t>passos</a:t>
+              </a:r>
+              <a:r>
+                <a:rPr lang="en-US" sz="800" dirty="0">
+                  <a:latin typeface="Times New Roman" panose="02020603050405020304" pitchFamily="18" charset="0"/>
+                  <a:cs typeface="Times New Roman" panose="02020603050405020304" pitchFamily="18" charset="0"/>
+                </a:rPr>
+                <a:t>. </a:t>
+              </a:r>
+              <a:r>
+                <a:rPr lang="en-US" sz="800" dirty="0" err="1">
+                  <a:latin typeface="Times New Roman" panose="02020603050405020304" pitchFamily="18" charset="0"/>
+                  <a:cs typeface="Times New Roman" panose="02020603050405020304" pitchFamily="18" charset="0"/>
+                </a:rPr>
+                <a:t>Após</a:t>
+              </a:r>
+              <a:r>
+                <a:rPr lang="en-US" sz="800" dirty="0">
+                  <a:latin typeface="Times New Roman" panose="02020603050405020304" pitchFamily="18" charset="0"/>
+                  <a:cs typeface="Times New Roman" panose="02020603050405020304" pitchFamily="18" charset="0"/>
+                </a:rPr>
+                <a:t> a reunião, as contribuições da equipe são acrescentadas. </a:t>
               </a:r>
               <a:endParaRPr sz="800" b="0" i="0" u="none" strike="noStrike" cap="none" dirty="0">
                 <a:solidFill>
@@ -9657,8 +9673,8 @@
           </p:nvSpPr>
           <p:spPr>
             <a:xfrm>
-              <a:off x="30050" y="1490225"/>
-              <a:ext cx="4411200" cy="2380500"/>
+              <a:off x="27432" y="1563624"/>
+              <a:ext cx="3611880" cy="2139695"/>
             </a:xfrm>
             <a:prstGeom prst="rect">
               <a:avLst/>
@@ -9743,7 +9759,7 @@
                   <a:cs typeface="Times New Roman"/>
                   <a:sym typeface="Times New Roman"/>
                 </a:rPr>
-                <a:t>ACTIVITIES</a:t>
+                <a:t>ATIVIDADES</a:t>
               </a:r>
               <a:r>
                 <a:rPr lang="pt-BR" sz="900" b="0" i="0" u="none" strike="noStrike" cap="none" dirty="0">
@@ -9765,14 +9781,42 @@
                   <a:latin typeface="Times New Roman" panose="02020603050405020304" pitchFamily="18" charset="0"/>
                   <a:cs typeface="Times New Roman" panose="02020603050405020304" pitchFamily="18" charset="0"/>
                 </a:rPr>
-                <a:t>Answers: </a:t>
+                <a:t>Responde: </a:t>
               </a:r>
               <a:r>
                 <a:rPr lang="en-US" sz="800" dirty="0">
                   <a:latin typeface="Times New Roman" panose="02020603050405020304" pitchFamily="18" charset="0"/>
                   <a:cs typeface="Times New Roman" panose="02020603050405020304" pitchFamily="18" charset="0"/>
                 </a:rPr>
-                <a:t>what we agreed to do, and where each item stands.</a:t>
+                <a:t>o que foi acordado fazer e em que </a:t>
+              </a:r>
+              <a:r>
+                <a:rPr lang="en-US" sz="800" dirty="0" err="1">
+                  <a:latin typeface="Times New Roman" panose="02020603050405020304" pitchFamily="18" charset="0"/>
+                  <a:cs typeface="Times New Roman" panose="02020603050405020304" pitchFamily="18" charset="0"/>
+                </a:rPr>
+                <a:t>estágio</a:t>
+              </a:r>
+              <a:r>
+                <a:rPr lang="en-US" sz="800" dirty="0">
+                  <a:latin typeface="Times New Roman" panose="02020603050405020304" pitchFamily="18" charset="0"/>
+                  <a:cs typeface="Times New Roman" panose="02020603050405020304" pitchFamily="18" charset="0"/>
+                </a:rPr>
+                <a:t> </a:t>
+              </a:r>
+              <a:r>
+                <a:rPr lang="en-US" sz="800" dirty="0" err="1">
+                  <a:latin typeface="Times New Roman" panose="02020603050405020304" pitchFamily="18" charset="0"/>
+                  <a:cs typeface="Times New Roman" panose="02020603050405020304" pitchFamily="18" charset="0"/>
+                </a:rPr>
+                <a:t>está</a:t>
+              </a:r>
+              <a:r>
+                <a:rPr lang="en-US" sz="800" dirty="0">
+                  <a:latin typeface="Times New Roman" panose="02020603050405020304" pitchFamily="18" charset="0"/>
+                  <a:cs typeface="Times New Roman" panose="02020603050405020304" pitchFamily="18" charset="0"/>
+                </a:rPr>
+                <a:t>.</a:t>
               </a:r>
             </a:p>
             <a:p>
@@ -9821,7 +9865,7 @@
                   <a:latin typeface="Times New Roman" panose="02020603050405020304" pitchFamily="18" charset="0"/>
                   <a:cs typeface="Times New Roman" panose="02020603050405020304" pitchFamily="18" charset="0"/>
                 </a:rPr>
-                <a:t>The cycle's activity list, fixed at kickoff, three to six items. Separated into 3 categories: done (light gray in strikethrough), in progress (black), and planned (light gray). Start with verbs in infinitive/imperative (Commission, Validate, Quantify, Fit, Measure, Select, Decide, Document)</a:t>
+                <a:t>Lista definida no início do ciclo, de três a seis itens. Cada item: verbo no infinitivo (Comissionar, Validar, Ajustar, Medir, Decidir, Documentar) e data-alvo de conclusão. Categorias: concluída (cinza-claro tachado), em andamento (preto) e planejada (cinza-claro). Se a data escorregar, manter a original entre parênteses: — 03/10 (alvo 19/09).</a:t>
               </a:r>
             </a:p>
             <a:p>
@@ -9883,7 +9927,7 @@
                   <a:latin typeface="Times New Roman" panose="02020603050405020304" pitchFamily="18" charset="0"/>
                   <a:cs typeface="Times New Roman" panose="02020603050405020304" pitchFamily="18" charset="0"/>
                 </a:rPr>
-                <a:t>Fit compressor performance map to manufacturer data</a:t>
+                <a:t>Ajustar o mapa de desempenho do compressor aos dados do fabricante — 05/09</a:t>
               </a:r>
             </a:p>
             <a:p>
@@ -9909,7 +9953,7 @@
                   <a:latin typeface="Times New Roman" panose="02020603050405020304" pitchFamily="18" charset="0"/>
                   <a:cs typeface="Times New Roman" panose="02020603050405020304" pitchFamily="18" charset="0"/>
                 </a:rPr>
-                <a:t>Commission heat pump on DAC 15TA</a:t>
+                <a:t>Comissionar a bomba de calor no reator DAC 15TA — 19/09</a:t>
               </a:r>
             </a:p>
             <a:p>
@@ -9940,7 +9984,7 @@
                   <a:latin typeface="Times New Roman" panose="02020603050405020304" pitchFamily="18" charset="0"/>
                   <a:cs typeface="Times New Roman" panose="02020603050405020304" pitchFamily="18" charset="0"/>
                 </a:rPr>
-                <a:t>Validate steady-state model against 60–80 °C tests</a:t>
+                <a:t>Validar o modelo em regime permanente com os ensaios de 60–80 °C — 03/10</a:t>
               </a:r>
               <a:endParaRPr sz="800" i="1" u="none" strike="noStrike" cap="none" dirty="0">
                 <a:solidFill>
@@ -10047,308 +10091,6 @@
             </a:p>
           </p:txBody>
         </p:sp>
-        <p:sp>
-          <p:nvSpPr>
-            <p:cNvPr id="151" name="Google Shape;151;p32"/>
-            <p:cNvSpPr/>
-            <p:nvPr/>
-          </p:nvSpPr>
-          <p:spPr>
-            <a:xfrm>
-              <a:off x="25550" y="3962500"/>
-              <a:ext cx="4477500" cy="1135200"/>
-            </a:xfrm>
-            <a:prstGeom prst="rect">
-              <a:avLst/>
-            </a:prstGeom>
-            <a:solidFill>
-              <a:srgbClr val="FFFFFF"/>
-            </a:solidFill>
-            <a:ln w="9525" cap="flat" cmpd="sng">
-              <a:solidFill>
-                <a:srgbClr val="666666"/>
-              </a:solidFill>
-              <a:prstDash val="solid"/>
-              <a:round/>
-              <a:headEnd type="none" w="sm" len="sm"/>
-              <a:tailEnd type="none" w="sm" len="sm"/>
-            </a:ln>
-          </p:spPr>
-          <p:txBody>
-            <a:bodyPr spcFirstLastPara="1" wrap="square" lIns="91425" tIns="0" rIns="91425" bIns="91425" anchor="t" anchorCtr="0">
-              <a:noAutofit/>
-            </a:bodyPr>
-            <a:lstStyle/>
-            <a:p>
-              <a:pPr marL="0" marR="0" lvl="0" indent="0" algn="l" rtl="0">
-                <a:lnSpc>
-                  <a:spcPct val="100000"/>
-                </a:lnSpc>
-                <a:spcBef>
-                  <a:spcPts val="0"/>
-                </a:spcBef>
-                <a:spcAft>
-                  <a:spcPts val="0"/>
-                </a:spcAft>
-                <a:buClr>
-                  <a:srgbClr val="000000"/>
-                </a:buClr>
-                <a:buSzPts val="200"/>
-                <a:buFont typeface="Arial"/>
-                <a:buNone/>
-              </a:pPr>
-              <a:endParaRPr sz="200" b="1" i="0" u="none" strike="noStrike" cap="none" dirty="0">
-                <a:solidFill>
-                  <a:srgbClr val="1E4E79"/>
-                </a:solidFill>
-                <a:highlight>
-                  <a:srgbClr val="FFFFFF"/>
-                </a:highlight>
-                <a:latin typeface="Times New Roman"/>
-                <a:ea typeface="Times New Roman"/>
-                <a:cs typeface="Times New Roman"/>
-                <a:sym typeface="Times New Roman"/>
-              </a:endParaRPr>
-            </a:p>
-            <a:p>
-              <a:pPr marL="0" marR="0" lvl="0" indent="0" algn="l" rtl="0">
-                <a:lnSpc>
-                  <a:spcPct val="100000"/>
-                </a:lnSpc>
-                <a:spcBef>
-                  <a:spcPts val="0"/>
-                </a:spcBef>
-                <a:spcAft>
-                  <a:spcPts val="0"/>
-                </a:spcAft>
-                <a:buClr>
-                  <a:srgbClr val="000000"/>
-                </a:buClr>
-                <a:buSzPts val="900"/>
-                <a:buFont typeface="Arial"/>
-                <a:buNone/>
-              </a:pPr>
-              <a:r>
-                <a:rPr lang="pt-BR" sz="900" b="1" i="0" u="none" strike="noStrike" cap="none" dirty="0">
-                  <a:solidFill>
-                    <a:srgbClr val="1E4E79"/>
-                  </a:solidFill>
-                  <a:highlight>
-                    <a:srgbClr val="FFFFFF"/>
-                  </a:highlight>
-                  <a:latin typeface="Times New Roman"/>
-                  <a:ea typeface="Times New Roman"/>
-                  <a:cs typeface="Times New Roman"/>
-                  <a:sym typeface="Times New Roman"/>
-                </a:rPr>
-                <a:t>OBSTACLES </a:t>
-              </a:r>
-              <a:r>
-                <a:rPr lang="pt-BR" sz="900" b="0" i="0" u="none" strike="noStrike" cap="none" dirty="0">
-                  <a:solidFill>
-                    <a:srgbClr val="000000"/>
-                  </a:solidFill>
-                  <a:highlight>
-                    <a:srgbClr val="FFFFFF"/>
-                  </a:highlight>
-                  <a:latin typeface="Times New Roman"/>
-                  <a:ea typeface="Times New Roman"/>
-                  <a:cs typeface="Times New Roman"/>
-                  <a:sym typeface="Times New Roman"/>
-                </a:rPr>
-                <a:t>| </a:t>
-              </a:r>
-              <a:r>
-                <a:rPr lang="en-US" sz="800" b="1" dirty="0">
-                  <a:latin typeface="Times New Roman" panose="02020603050405020304" pitchFamily="18" charset="0"/>
-                  <a:cs typeface="Times New Roman" panose="02020603050405020304" pitchFamily="18" charset="0"/>
-                </a:rPr>
-                <a:t>Answers:</a:t>
-              </a:r>
-              <a:r>
-                <a:rPr lang="en-US" sz="800" dirty="0">
-                  <a:latin typeface="Times New Roman" panose="02020603050405020304" pitchFamily="18" charset="0"/>
-                  <a:cs typeface="Times New Roman" panose="02020603050405020304" pitchFamily="18" charset="0"/>
-                </a:rPr>
-                <a:t> what is in the way to meet the objective.</a:t>
-              </a:r>
-              <a:endParaRPr lang="pt-BR" sz="800" dirty="0">
-                <a:highlight>
-                  <a:srgbClr val="FFFFFF"/>
-                </a:highlight>
-                <a:latin typeface="Times New Roman" panose="02020603050405020304" pitchFamily="18" charset="0"/>
-                <a:cs typeface="Times New Roman" panose="02020603050405020304" pitchFamily="18" charset="0"/>
-                <a:sym typeface="Times New Roman"/>
-              </a:endParaRPr>
-            </a:p>
-            <a:p>
-              <a:pPr marL="0" marR="0" lvl="0" indent="0" algn="l" rtl="0">
-                <a:lnSpc>
-                  <a:spcPct val="100000"/>
-                </a:lnSpc>
-                <a:spcBef>
-                  <a:spcPts val="0"/>
-                </a:spcBef>
-                <a:spcAft>
-                  <a:spcPts val="0"/>
-                </a:spcAft>
-                <a:buClr>
-                  <a:srgbClr val="000000"/>
-                </a:buClr>
-                <a:buSzPts val="900"/>
-                <a:buFont typeface="Arial"/>
-                <a:buNone/>
-              </a:pPr>
-              <a:endParaRPr lang="pt-BR" sz="800" b="0" i="0" u="none" strike="noStrike" cap="none" dirty="0">
-                <a:solidFill>
-                  <a:srgbClr val="000000"/>
-                </a:solidFill>
-                <a:highlight>
-                  <a:srgbClr val="FFFFFF"/>
-                </a:highlight>
-                <a:latin typeface="Times New Roman" panose="02020603050405020304" pitchFamily="18" charset="0"/>
-                <a:ea typeface="Times New Roman"/>
-                <a:cs typeface="Times New Roman" panose="02020603050405020304" pitchFamily="18" charset="0"/>
-                <a:sym typeface="Times New Roman"/>
-              </a:endParaRPr>
-            </a:p>
-            <a:p>
-              <a:pPr marL="228600" marR="0" lvl="0" indent="-228600" algn="l" rtl="0">
-                <a:lnSpc>
-                  <a:spcPct val="100000"/>
-                </a:lnSpc>
-                <a:spcBef>
-                  <a:spcPts val="0"/>
-                </a:spcBef>
-                <a:spcAft>
-                  <a:spcPts val="0"/>
-                </a:spcAft>
-                <a:buClr>
-                  <a:srgbClr val="000000"/>
-                </a:buClr>
-                <a:buSzPts val="900"/>
-                <a:buFont typeface="+mj-lt"/>
-                <a:buAutoNum type="arabicPeriod"/>
-              </a:pPr>
-              <a:r>
-                <a:rPr lang="en-US" sz="800" i="1" dirty="0">
-                  <a:latin typeface="Times New Roman" panose="02020603050405020304" pitchFamily="18" charset="0"/>
-                  <a:cs typeface="Times New Roman" panose="02020603050405020304" pitchFamily="18" charset="0"/>
-                </a:rPr>
-                <a:t>Manufacturer data covers only 35–75 °C condensing, leaving the 85–120 °C range needed for DAC unsupported by any fit</a:t>
-              </a:r>
-            </a:p>
-            <a:p>
-              <a:pPr marL="228600" marR="0" lvl="0" indent="-228600" algn="l" rtl="0">
-                <a:lnSpc>
-                  <a:spcPct val="100000"/>
-                </a:lnSpc>
-                <a:spcBef>
-                  <a:spcPts val="0"/>
-                </a:spcBef>
-                <a:spcAft>
-                  <a:spcPts val="0"/>
-                </a:spcAft>
-                <a:buClr>
-                  <a:srgbClr val="000000"/>
-                </a:buClr>
-                <a:buSzPts val="900"/>
-                <a:buFont typeface="+mj-lt"/>
-                <a:buAutoNum type="arabicPeriod"/>
-              </a:pPr>
-              <a:r>
-                <a:rPr lang="en-US" sz="800" i="1" dirty="0">
-                  <a:latin typeface="Times New Roman" panose="02020603050405020304" pitchFamily="18" charset="0"/>
-                  <a:cs typeface="Times New Roman" panose="02020603050405020304" pitchFamily="18" charset="0"/>
-                </a:rPr>
-                <a:t>Heat pump delivery to PUCRS slipped to 15/09</a:t>
-              </a:r>
-            </a:p>
-            <a:p>
-              <a:pPr marL="228600" marR="0" lvl="0" indent="-228600" algn="l" rtl="0">
-                <a:lnSpc>
-                  <a:spcPct val="100000"/>
-                </a:lnSpc>
-                <a:spcBef>
-                  <a:spcPts val="0"/>
-                </a:spcBef>
-                <a:spcAft>
-                  <a:spcPts val="0"/>
-                </a:spcAft>
-                <a:buClr>
-                  <a:srgbClr val="000000"/>
-                </a:buClr>
-                <a:buSzPts val="900"/>
-                <a:buFont typeface="+mj-lt"/>
-                <a:buAutoNum type="arabicPeriod"/>
-              </a:pPr>
-              <a:r>
-                <a:rPr lang="en-US" sz="800" i="1" dirty="0">
-                  <a:latin typeface="Times New Roman" panose="02020603050405020304" pitchFamily="18" charset="0"/>
-                  <a:cs typeface="Times New Roman" panose="02020603050405020304" pitchFamily="18" charset="0"/>
-                </a:rPr>
-                <a:t>Validation cannot start until the heat pump is commissioned</a:t>
-              </a:r>
-            </a:p>
-            <a:p>
-              <a:pPr marL="0" marR="0" lvl="0" indent="0" algn="l" rtl="0">
-                <a:lnSpc>
-                  <a:spcPct val="100000"/>
-                </a:lnSpc>
-                <a:spcBef>
-                  <a:spcPts val="0"/>
-                </a:spcBef>
-                <a:spcAft>
-                  <a:spcPts val="0"/>
-                </a:spcAft>
-                <a:buClr>
-                  <a:srgbClr val="000000"/>
-                </a:buClr>
-                <a:buSzPts val="900"/>
-                <a:buFont typeface="Arial"/>
-                <a:buNone/>
-              </a:pPr>
-              <a:endParaRPr sz="800" b="0" i="0" u="none" strike="noStrike" cap="none" dirty="0">
-                <a:solidFill>
-                  <a:srgbClr val="000000"/>
-                </a:solidFill>
-                <a:highlight>
-                  <a:srgbClr val="FFFFFF"/>
-                </a:highlight>
-                <a:latin typeface="Times New Roman" panose="02020603050405020304" pitchFamily="18" charset="0"/>
-                <a:ea typeface="Times New Roman"/>
-                <a:cs typeface="Times New Roman" panose="02020603050405020304" pitchFamily="18" charset="0"/>
-                <a:sym typeface="Times New Roman"/>
-              </a:endParaRPr>
-            </a:p>
-          </p:txBody>
-        </p:sp>
-        <p:cxnSp>
-          <p:nvCxnSpPr>
-            <p:cNvPr id="152" name="Google Shape;152;p32"/>
-            <p:cNvCxnSpPr/>
-            <p:nvPr/>
-          </p:nvCxnSpPr>
-          <p:spPr>
-            <a:xfrm>
-              <a:off x="-2100" y="3911975"/>
-              <a:ext cx="9148200" cy="9300"/>
-            </a:xfrm>
-            <a:prstGeom prst="straightConnector1">
-              <a:avLst/>
-            </a:prstGeom>
-            <a:noFill/>
-            <a:ln w="19050" cap="flat" cmpd="sng">
-              <a:solidFill>
-                <a:schemeClr val="dk2"/>
-              </a:solidFill>
-              <a:prstDash val="solid"/>
-              <a:round/>
-              <a:headEnd type="none" w="sm" len="sm"/>
-              <a:tailEnd type="none" w="sm" len="sm"/>
-            </a:ln>
-          </p:spPr>
-        </p:cxnSp>
       </p:grpSp>
       <p:pic>
         <p:nvPicPr>
@@ -10410,10 +10152,10 @@
         </p:nvGrpSpPr>
         <p:grpSpPr>
           <a:xfrm>
-            <a:off x="35775" y="-25250"/>
-            <a:ext cx="9148200" cy="5097700"/>
-            <a:chOff x="-2100" y="0"/>
-            <a:chExt cx="9148200" cy="5097700"/>
+            <a:off x="65307" y="47902"/>
+            <a:ext cx="9070848" cy="5001768"/>
+            <a:chOff x="27432" y="73152"/>
+            <a:chExt cx="9070848" cy="5001768"/>
           </a:xfrm>
         </p:grpSpPr>
         <p:sp>
@@ -10424,8 +10166,8 @@
           </p:nvSpPr>
           <p:spPr>
             <a:xfrm>
-              <a:off x="30050" y="73350"/>
-              <a:ext cx="4411200" cy="542100"/>
+              <a:off x="27432" y="73152"/>
+              <a:ext cx="3611880" cy="502920"/>
             </a:xfrm>
             <a:prstGeom prst="rect">
               <a:avLst/>
@@ -10479,7 +10221,7 @@
                   <a:cs typeface="Times New Roman"/>
                   <a:sym typeface="Times New Roman"/>
                 </a:rPr>
-                <a:t>1. FOLLOW-UP - OWNER</a:t>
+                <a:t>1. ACOMPANHAMENTO - RESPONSÁVEL</a:t>
               </a:r>
               <a:endParaRPr dirty="0">
                 <a:highlight>
@@ -10515,7 +10257,7 @@
                   <a:cs typeface="Times New Roman"/>
                   <a:sym typeface="Times New Roman"/>
                 </a:rPr>
-                <a:t>DD/NN/AAAA - DD/MM/AAAA</a:t>
+                <a:t>DD/MM/AAAA - DD/MM/AAAA</a:t>
               </a:r>
               <a:endParaRPr dirty="0"/>
             </a:p>
@@ -10529,8 +10271,8 @@
           </p:nvSpPr>
           <p:spPr>
             <a:xfrm>
-              <a:off x="30050" y="658825"/>
-              <a:ext cx="4411200" cy="768600"/>
+              <a:off x="27432" y="621792"/>
+              <a:ext cx="3611880" cy="896112"/>
             </a:xfrm>
             <a:prstGeom prst="rect">
               <a:avLst/>
@@ -10615,7 +10357,7 @@
                   <a:cs typeface="Times New Roman"/>
                   <a:sym typeface="Times New Roman"/>
                 </a:rPr>
-                <a:t>OBJECTIVE</a:t>
+                <a:t>OBJETIVO</a:t>
               </a:r>
               <a:r>
                 <a:rPr lang="pt-BR" sz="900" b="0" i="0" u="none" strike="noStrike" cap="none" dirty="0">
@@ -10637,14 +10379,14 @@
                   <a:latin typeface="Times New Roman" panose="02020603050405020304" pitchFamily="18" charset="0"/>
                   <a:cs typeface="Times New Roman" panose="02020603050405020304" pitchFamily="18" charset="0"/>
                 </a:rPr>
-                <a:t>Answers: </a:t>
+                <a:t>Responde: </a:t>
               </a:r>
               <a:r>
                 <a:rPr lang="en-US" sz="800" dirty="0">
                   <a:latin typeface="Times New Roman" panose="02020603050405020304" pitchFamily="18" charset="0"/>
                   <a:cs typeface="Times New Roman" panose="02020603050405020304" pitchFamily="18" charset="0"/>
                 </a:rPr>
-                <a:t>what this cycle is for.</a:t>
+                <a:t>para que serve este ciclo.</a:t>
               </a:r>
             </a:p>
             <a:p>
@@ -10690,32 +10432,6 @@
             </a:p>
           </p:txBody>
         </p:sp>
-        <p:cxnSp>
-          <p:nvCxnSpPr>
-            <p:cNvPr id="147" name="Google Shape;147;p32"/>
-            <p:cNvCxnSpPr/>
-            <p:nvPr/>
-          </p:nvCxnSpPr>
-          <p:spPr>
-            <a:xfrm>
-              <a:off x="4502950" y="0"/>
-              <a:ext cx="12000" cy="3921900"/>
-            </a:xfrm>
-            <a:prstGeom prst="straightConnector1">
-              <a:avLst/>
-            </a:prstGeom>
-            <a:noFill/>
-            <a:ln w="19050" cap="flat" cmpd="sng">
-              <a:solidFill>
-                <a:schemeClr val="dk2"/>
-              </a:solidFill>
-              <a:prstDash val="solid"/>
-              <a:round/>
-              <a:headEnd type="none" w="sm" len="sm"/>
-              <a:tailEnd type="none" w="sm" len="sm"/>
-            </a:ln>
-          </p:spPr>
-        </p:cxnSp>
         <p:sp>
           <p:nvSpPr>
             <p:cNvPr id="148" name="Google Shape;148;p32"/>
@@ -10724,8 +10440,8 @@
           </p:nvSpPr>
           <p:spPr>
             <a:xfrm>
-              <a:off x="4572000" y="73350"/>
-              <a:ext cx="4510500" cy="3797400"/>
+              <a:off x="3730752" y="73152"/>
+              <a:ext cx="5367528" cy="5001768"/>
             </a:xfrm>
             <a:prstGeom prst="rect">
               <a:avLst/>
@@ -10779,7 +10495,7 @@
                   <a:cs typeface="Times New Roman"/>
                   <a:sym typeface="Times New Roman"/>
                 </a:rPr>
-                <a:t>RESULTS</a:t>
+                <a:t>RESULTADOS</a:t>
               </a:r>
               <a:r>
                 <a:rPr lang="pt-BR" sz="900" b="0" i="0" u="none" strike="noStrike" cap="none" dirty="0">
@@ -10801,14 +10517,14 @@
                   <a:latin typeface="Times New Roman" panose="02020603050405020304" pitchFamily="18" charset="0"/>
                   <a:cs typeface="Times New Roman" panose="02020603050405020304" pitchFamily="18" charset="0"/>
                 </a:rPr>
-                <a:t>Answers:</a:t>
+                <a:t>Responde:</a:t>
               </a:r>
               <a:r>
                 <a:rPr lang="en-US" sz="800" dirty="0">
                   <a:latin typeface="Times New Roman" panose="02020603050405020304" pitchFamily="18" charset="0"/>
                   <a:cs typeface="Times New Roman" panose="02020603050405020304" pitchFamily="18" charset="0"/>
                 </a:rPr>
-                <a:t> what do we now know that we didn't last week.</a:t>
+                <a:t> o que sabemos agora que não sabíamos na semana passada.</a:t>
               </a:r>
               <a:endParaRPr sz="800" dirty="0">
                 <a:latin typeface="Times New Roman" panose="02020603050405020304" pitchFamily="18" charset="0"/>
@@ -10838,6 +10554,101 @@
                 <a:sym typeface="Times New Roman"/>
               </a:endParaRPr>
             </a:p>
+            <a:p>
+              <a:pPr marL="0" lvl="0" indent="0" algn="l" rtl="0">
+                <a:spcBef>
+                  <a:spcPts val="0"/>
+                </a:spcBef>
+                <a:spcAft>
+                  <a:spcPts val="0"/>
+                </a:spcAft>
+                <a:buNone/>
+              </a:pPr>
+              <a:r>
+                <a:rPr lang="en-US" sz="800" dirty="0">
+                  <a:latin typeface="Times New Roman" panose="02020603050405020304" pitchFamily="18" charset="0"/>
+                  <a:cs typeface="Times New Roman" panose="02020603050405020304" pitchFamily="18" charset="0"/>
+                </a:rPr>
+                <a:t>Evidência, não atividade. Dados, não narrativa</a:t>
+              </a:r>
+              <a:r>
+                <a:rPr lang="en-US" sz="800" b="1" dirty="0">
+                  <a:latin typeface="Times New Roman" panose="02020603050405020304" pitchFamily="18" charset="0"/>
+                  <a:cs typeface="Times New Roman" panose="02020603050405020304" pitchFamily="18" charset="0"/>
+                </a:rPr>
+                <a:t>.</a:t>
+              </a:r>
+              <a:r>
+                <a:rPr lang="en-US" sz="800" dirty="0">
+                  <a:latin typeface="Times New Roman" panose="02020603050405020304" pitchFamily="18" charset="0"/>
+                  <a:cs typeface="Times New Roman" panose="02020603050405020304" pitchFamily="18" charset="0"/>
+                </a:rPr>
+                <a:t> Figuras, tabelas e frases dizendo o que elas mostram. </a:t>
+              </a:r>
+              <a:endParaRPr sz="800" dirty="0">
+                <a:highlight>
+                  <a:srgbClr val="FFFFFF"/>
+                </a:highlight>
+                <a:latin typeface="Times New Roman" panose="02020603050405020304" pitchFamily="18" charset="0"/>
+                <a:ea typeface="Times New Roman"/>
+                <a:cs typeface="Times New Roman" panose="02020603050405020304" pitchFamily="18" charset="0"/>
+                <a:sym typeface="Times New Roman"/>
+              </a:endParaRPr>
+            </a:p>
+            <a:p>
+              <a:pPr marL="457200" marR="0" lvl="0" indent="0" algn="l" rtl="0">
+                <a:lnSpc>
+                  <a:spcPct val="100000"/>
+                </a:lnSpc>
+                <a:spcBef>
+                  <a:spcPts val="0"/>
+                </a:spcBef>
+                <a:spcAft>
+                  <a:spcPts val="0"/>
+                </a:spcAft>
+                <a:buNone/>
+              </a:pPr>
+              <a:endParaRPr sz="900" dirty="0">
+                <a:highlight>
+                  <a:srgbClr val="FFFFFF"/>
+                </a:highlight>
+                <a:latin typeface="Times New Roman"/>
+                <a:ea typeface="Times New Roman"/>
+                <a:cs typeface="Times New Roman"/>
+                <a:sym typeface="Times New Roman"/>
+              </a:endParaRPr>
+            </a:p>
+            <a:p>
+              <a:pPr marL="228600" marR="0" lvl="0" indent="-171450" algn="l" rtl="0">
+                <a:lnSpc>
+                  <a:spcPct val="100000"/>
+                </a:lnSpc>
+                <a:spcBef>
+                  <a:spcPts val="0"/>
+                </a:spcBef>
+                <a:spcAft>
+                  <a:spcPts val="0"/>
+                </a:spcAft>
+                <a:buClr>
+                  <a:srgbClr val="000000"/>
+                </a:buClr>
+                <a:buSzPts val="900"/>
+                <a:buFont typeface="Arial"/>
+                <a:buNone/>
+              </a:pPr>
+              <a:endParaRPr sz="900" b="0" i="0" u="none" strike="noStrike" cap="none" dirty="0">
+                <a:solidFill>
+                  <a:srgbClr val="000000"/>
+                </a:solidFill>
+                <a:highlight>
+                  <a:srgbClr val="FFFFFF"/>
+                </a:highlight>
+                <a:latin typeface="Times New Roman"/>
+                <a:ea typeface="Times New Roman"/>
+                <a:cs typeface="Times New Roman"/>
+                <a:sym typeface="Times New Roman"/>
+              </a:endParaRPr>
+            </a:p>
           </p:txBody>
         </p:sp>
         <p:sp>
@@ -10848,8 +10659,8 @@
           </p:nvSpPr>
           <p:spPr>
             <a:xfrm>
-              <a:off x="4514950" y="3962500"/>
-              <a:ext cx="4574100" cy="1135200"/>
+              <a:off x="27432" y="3749040"/>
+              <a:ext cx="3611880" cy="1325880"/>
             </a:xfrm>
             <a:prstGeom prst="rect">
               <a:avLst/>
@@ -10934,7 +10745,7 @@
                   <a:cs typeface="Times New Roman"/>
                   <a:sym typeface="Times New Roman"/>
                 </a:rPr>
-                <a:t>NEXT STEPS</a:t>
+                <a:t>PRÓXIMOS PASSOS</a:t>
               </a:r>
               <a:r>
                 <a:rPr lang="pt-BR" sz="900" b="0" i="0" u="none" strike="noStrike" cap="none" dirty="0">
@@ -10956,14 +10767,14 @@
                   <a:latin typeface="Times New Roman" panose="02020603050405020304" pitchFamily="18" charset="0"/>
                   <a:cs typeface="Times New Roman" panose="02020603050405020304" pitchFamily="18" charset="0"/>
                 </a:rPr>
-                <a:t>Answers:</a:t>
+                <a:t>Responde:</a:t>
               </a:r>
               <a:r>
                 <a:rPr lang="en-US" sz="800" dirty="0">
                   <a:latin typeface="Times New Roman" panose="02020603050405020304" pitchFamily="18" charset="0"/>
                   <a:cs typeface="Times New Roman" panose="02020603050405020304" pitchFamily="18" charset="0"/>
                 </a:rPr>
-                <a:t> what will be true at the next meeting.</a:t>
+                <a:t> o que será verdade na próxima reunião.</a:t>
               </a:r>
               <a:endParaRPr lang="en-US" sz="800" dirty="0">
                 <a:highlight>
@@ -11015,8 +10826,8 @@
           </p:nvSpPr>
           <p:spPr>
             <a:xfrm>
-              <a:off x="30050" y="1490225"/>
-              <a:ext cx="4411200" cy="2380500"/>
+              <a:off x="27432" y="1563624"/>
+              <a:ext cx="3611880" cy="2139695"/>
             </a:xfrm>
             <a:prstGeom prst="rect">
               <a:avLst/>
@@ -11101,7 +10912,7 @@
                   <a:cs typeface="Times New Roman"/>
                   <a:sym typeface="Times New Roman"/>
                 </a:rPr>
-                <a:t>ACTIVITIES</a:t>
+                <a:t>ATIVIDADES</a:t>
               </a:r>
               <a:r>
                 <a:rPr lang="pt-BR" sz="900" b="0" i="0" u="none" strike="noStrike" cap="none" dirty="0">
@@ -11123,14 +10934,42 @@
                   <a:latin typeface="Times New Roman" panose="02020603050405020304" pitchFamily="18" charset="0"/>
                   <a:cs typeface="Times New Roman" panose="02020603050405020304" pitchFamily="18" charset="0"/>
                 </a:rPr>
-                <a:t>Answers: </a:t>
+                <a:t>Responde: </a:t>
               </a:r>
               <a:r>
                 <a:rPr lang="en-US" sz="800" dirty="0">
                   <a:latin typeface="Times New Roman" panose="02020603050405020304" pitchFamily="18" charset="0"/>
                   <a:cs typeface="Times New Roman" panose="02020603050405020304" pitchFamily="18" charset="0"/>
                 </a:rPr>
-                <a:t>what we agreed to do, and where each item stands.</a:t>
+                <a:t>o que foi acordado fazer e em que </a:t>
+              </a:r>
+              <a:r>
+                <a:rPr lang="en-US" sz="800" dirty="0" err="1">
+                  <a:latin typeface="Times New Roman" panose="02020603050405020304" pitchFamily="18" charset="0"/>
+                  <a:cs typeface="Times New Roman" panose="02020603050405020304" pitchFamily="18" charset="0"/>
+                </a:rPr>
+                <a:t>estágio</a:t>
+              </a:r>
+              <a:r>
+                <a:rPr lang="en-US" sz="800" dirty="0">
+                  <a:latin typeface="Times New Roman" panose="02020603050405020304" pitchFamily="18" charset="0"/>
+                  <a:cs typeface="Times New Roman" panose="02020603050405020304" pitchFamily="18" charset="0"/>
+                </a:rPr>
+                <a:t> </a:t>
+              </a:r>
+              <a:r>
+                <a:rPr lang="en-US" sz="800" dirty="0" err="1">
+                  <a:latin typeface="Times New Roman" panose="02020603050405020304" pitchFamily="18" charset="0"/>
+                  <a:cs typeface="Times New Roman" panose="02020603050405020304" pitchFamily="18" charset="0"/>
+                </a:rPr>
+                <a:t>está</a:t>
+              </a:r>
+              <a:r>
+                <a:rPr lang="en-US" sz="800" dirty="0">
+                  <a:latin typeface="Times New Roman" panose="02020603050405020304" pitchFamily="18" charset="0"/>
+                  <a:cs typeface="Times New Roman" panose="02020603050405020304" pitchFamily="18" charset="0"/>
+                </a:rPr>
+                <a:t>.</a:t>
               </a:r>
             </a:p>
             <a:p>
@@ -11246,230 +11085,6 @@
             </a:p>
           </p:txBody>
         </p:sp>
-        <p:sp>
-          <p:nvSpPr>
-            <p:cNvPr id="151" name="Google Shape;151;p32"/>
-            <p:cNvSpPr/>
-            <p:nvPr/>
-          </p:nvSpPr>
-          <p:spPr>
-            <a:xfrm>
-              <a:off x="25550" y="3962500"/>
-              <a:ext cx="4477500" cy="1135200"/>
-            </a:xfrm>
-            <a:prstGeom prst="rect">
-              <a:avLst/>
-            </a:prstGeom>
-            <a:solidFill>
-              <a:srgbClr val="FFFFFF"/>
-            </a:solidFill>
-            <a:ln w="9525" cap="flat" cmpd="sng">
-              <a:solidFill>
-                <a:srgbClr val="666666"/>
-              </a:solidFill>
-              <a:prstDash val="solid"/>
-              <a:round/>
-              <a:headEnd type="none" w="sm" len="sm"/>
-              <a:tailEnd type="none" w="sm" len="sm"/>
-            </a:ln>
-          </p:spPr>
-          <p:txBody>
-            <a:bodyPr spcFirstLastPara="1" wrap="square" lIns="91425" tIns="0" rIns="91425" bIns="91425" anchor="t" anchorCtr="0">
-              <a:noAutofit/>
-            </a:bodyPr>
-            <a:lstStyle/>
-            <a:p>
-              <a:pPr marL="0" marR="0" lvl="0" indent="0" algn="l" rtl="0">
-                <a:lnSpc>
-                  <a:spcPct val="100000"/>
-                </a:lnSpc>
-                <a:spcBef>
-                  <a:spcPts val="0"/>
-                </a:spcBef>
-                <a:spcAft>
-                  <a:spcPts val="0"/>
-                </a:spcAft>
-                <a:buClr>
-                  <a:srgbClr val="000000"/>
-                </a:buClr>
-                <a:buSzPts val="200"/>
-                <a:buFont typeface="Arial"/>
-                <a:buNone/>
-              </a:pPr>
-              <a:endParaRPr sz="200" b="1" i="0" u="none" strike="noStrike" cap="none" dirty="0">
-                <a:solidFill>
-                  <a:srgbClr val="1E4E79"/>
-                </a:solidFill>
-                <a:highlight>
-                  <a:srgbClr val="FFFFFF"/>
-                </a:highlight>
-                <a:latin typeface="Times New Roman"/>
-                <a:ea typeface="Times New Roman"/>
-                <a:cs typeface="Times New Roman"/>
-                <a:sym typeface="Times New Roman"/>
-              </a:endParaRPr>
-            </a:p>
-            <a:p>
-              <a:pPr marL="0" marR="0" lvl="0" indent="0" algn="l" rtl="0">
-                <a:lnSpc>
-                  <a:spcPct val="100000"/>
-                </a:lnSpc>
-                <a:spcBef>
-                  <a:spcPts val="0"/>
-                </a:spcBef>
-                <a:spcAft>
-                  <a:spcPts val="0"/>
-                </a:spcAft>
-                <a:buClr>
-                  <a:srgbClr val="000000"/>
-                </a:buClr>
-                <a:buSzPts val="900"/>
-                <a:buFont typeface="Arial"/>
-                <a:buNone/>
-              </a:pPr>
-              <a:r>
-                <a:rPr lang="pt-BR" sz="900" b="1" i="0" u="none" strike="noStrike" cap="none" dirty="0">
-                  <a:solidFill>
-                    <a:srgbClr val="1E4E79"/>
-                  </a:solidFill>
-                  <a:highlight>
-                    <a:srgbClr val="FFFFFF"/>
-                  </a:highlight>
-                  <a:latin typeface="Times New Roman"/>
-                  <a:ea typeface="Times New Roman"/>
-                  <a:cs typeface="Times New Roman"/>
-                  <a:sym typeface="Times New Roman"/>
-                </a:rPr>
-                <a:t>OBSTACLES </a:t>
-              </a:r>
-              <a:r>
-                <a:rPr lang="pt-BR" sz="900" b="0" i="0" u="none" strike="noStrike" cap="none" dirty="0">
-                  <a:solidFill>
-                    <a:srgbClr val="000000"/>
-                  </a:solidFill>
-                  <a:highlight>
-                    <a:srgbClr val="FFFFFF"/>
-                  </a:highlight>
-                  <a:latin typeface="Times New Roman"/>
-                  <a:ea typeface="Times New Roman"/>
-                  <a:cs typeface="Times New Roman"/>
-                  <a:sym typeface="Times New Roman"/>
-                </a:rPr>
-                <a:t>| </a:t>
-              </a:r>
-              <a:r>
-                <a:rPr lang="en-US" sz="800" b="1" dirty="0">
-                  <a:latin typeface="Times New Roman" panose="02020603050405020304" pitchFamily="18" charset="0"/>
-                  <a:cs typeface="Times New Roman" panose="02020603050405020304" pitchFamily="18" charset="0"/>
-                </a:rPr>
-                <a:t>Answers:</a:t>
-              </a:r>
-              <a:r>
-                <a:rPr lang="en-US" sz="800" dirty="0">
-                  <a:latin typeface="Times New Roman" panose="02020603050405020304" pitchFamily="18" charset="0"/>
-                  <a:cs typeface="Times New Roman" panose="02020603050405020304" pitchFamily="18" charset="0"/>
-                </a:rPr>
-                <a:t> what is in the way to meet the objective.</a:t>
-              </a:r>
-              <a:endParaRPr lang="pt-BR" sz="800" dirty="0">
-                <a:highlight>
-                  <a:srgbClr val="FFFFFF"/>
-                </a:highlight>
-                <a:latin typeface="Times New Roman" panose="02020603050405020304" pitchFamily="18" charset="0"/>
-                <a:cs typeface="Times New Roman" panose="02020603050405020304" pitchFamily="18" charset="0"/>
-                <a:sym typeface="Times New Roman"/>
-              </a:endParaRPr>
-            </a:p>
-            <a:p>
-              <a:pPr marL="0" marR="0" lvl="0" indent="0" algn="l" rtl="0">
-                <a:lnSpc>
-                  <a:spcPct val="100000"/>
-                </a:lnSpc>
-                <a:spcBef>
-                  <a:spcPts val="0"/>
-                </a:spcBef>
-                <a:spcAft>
-                  <a:spcPts val="0"/>
-                </a:spcAft>
-                <a:buClr>
-                  <a:srgbClr val="000000"/>
-                </a:buClr>
-                <a:buSzPts val="900"/>
-                <a:buFont typeface="Arial"/>
-                <a:buNone/>
-              </a:pPr>
-              <a:endParaRPr lang="pt-BR" sz="800" b="0" i="0" u="none" strike="noStrike" cap="none" dirty="0">
-                <a:solidFill>
-                  <a:srgbClr val="000000"/>
-                </a:solidFill>
-                <a:highlight>
-                  <a:srgbClr val="FFFFFF"/>
-                </a:highlight>
-                <a:latin typeface="Times New Roman" panose="02020603050405020304" pitchFamily="18" charset="0"/>
-                <a:ea typeface="Times New Roman"/>
-                <a:cs typeface="Times New Roman" panose="02020603050405020304" pitchFamily="18" charset="0"/>
-                <a:sym typeface="Times New Roman"/>
-              </a:endParaRPr>
-            </a:p>
-            <a:p>
-              <a:pPr marL="0" marR="0" lvl="0" indent="0" algn="l" rtl="0">
-                <a:lnSpc>
-                  <a:spcPct val="100000"/>
-                </a:lnSpc>
-                <a:spcBef>
-                  <a:spcPts val="0"/>
-                </a:spcBef>
-                <a:spcAft>
-                  <a:spcPts val="0"/>
-                </a:spcAft>
-                <a:buClr>
-                  <a:srgbClr val="000000"/>
-                </a:buClr>
-                <a:buSzPts val="900"/>
-                <a:buFont typeface="Arial"/>
-                <a:buNone/>
-              </a:pPr>
-              <a:endParaRPr sz="800" b="0" i="0" u="none" strike="noStrike" cap="none" dirty="0">
-                <a:solidFill>
-                  <a:srgbClr val="000000"/>
-                </a:solidFill>
-                <a:highlight>
-                  <a:srgbClr val="FFFFFF"/>
-                </a:highlight>
-                <a:latin typeface="Times New Roman" panose="02020603050405020304" pitchFamily="18" charset="0"/>
-                <a:ea typeface="Times New Roman"/>
-                <a:cs typeface="Times New Roman" panose="02020603050405020304" pitchFamily="18" charset="0"/>
-                <a:sym typeface="Times New Roman"/>
-              </a:endParaRPr>
-            </a:p>
-          </p:txBody>
-        </p:sp>
-        <p:cxnSp>
-          <p:nvCxnSpPr>
-            <p:cNvPr id="152" name="Google Shape;152;p32"/>
-            <p:cNvCxnSpPr/>
-            <p:nvPr/>
-          </p:nvCxnSpPr>
-          <p:spPr>
-            <a:xfrm>
-              <a:off x="-2100" y="3911975"/>
-              <a:ext cx="9148200" cy="9300"/>
-            </a:xfrm>
-            <a:prstGeom prst="straightConnector1">
-              <a:avLst/>
-            </a:prstGeom>
-            <a:noFill/>
-            <a:ln w="19050" cap="flat" cmpd="sng">
-              <a:solidFill>
-                <a:schemeClr val="dk2"/>
-              </a:solidFill>
-              <a:prstDash val="solid"/>
-              <a:round/>
-              <a:headEnd type="none" w="sm" len="sm"/>
-              <a:tailEnd type="none" w="sm" len="sm"/>
-            </a:ln>
-          </p:spPr>
-        </p:cxnSp>
       </p:grpSp>
       <p:pic>
         <p:nvPicPr>
@@ -11501,7 +11116,7 @@
     </p:spTree>
     <p:extLst>
       <p:ext uri="{BB962C8B-B14F-4D97-AF65-F5344CB8AC3E}">
-        <p14:creationId xmlns:p14="http://schemas.microsoft.com/office/powerpoint/2010/main" val="1784183406"/>
+        <p14:creationId xmlns:p14="http://schemas.microsoft.com/office/powerpoint/2010/main" val="2666172763"/>
       </p:ext>
     </p:extLst>
   </p:cSld>

</xml_diff>